<commit_message>
finalized clippy params for smb and prpf8
</commit_message>
<xml_diff>
--- a/figures/datasetgenerationflowchart.pptx
+++ b/figures/datasetgenerationflowchart.pptx
@@ -261,7 +261,7 @@
           <a:p>
             <a:fld id="{0DAF61AA-5A98-4049-A93E-477E5505141A}" type="datetimeFigureOut">
               <a:rPr lang="en-US" smtClean="0"/>
-              <a:t>8/11/2026</a:t>
+              <a:t>8/20/2026</a:t>
             </a:fld>
             <a:endParaRPr lang="en-US" dirty="0"/>
           </a:p>
@@ -461,7 +461,7 @@
           <a:p>
             <a:fld id="{0DAF61AA-5A98-4049-A93E-477E5505141A}" type="datetimeFigureOut">
               <a:rPr lang="en-US" smtClean="0"/>
-              <a:t>8/11/2026</a:t>
+              <a:t>8/20/2026</a:t>
             </a:fld>
             <a:endParaRPr lang="en-US"/>
           </a:p>
@@ -671,7 +671,7 @@
           <a:p>
             <a:fld id="{0DAF61AA-5A98-4049-A93E-477E5505141A}" type="datetimeFigureOut">
               <a:rPr lang="en-US" smtClean="0"/>
-              <a:t>8/11/2026</a:t>
+              <a:t>8/20/2026</a:t>
             </a:fld>
             <a:endParaRPr lang="en-US"/>
           </a:p>
@@ -871,7 +871,7 @@
           <a:p>
             <a:fld id="{0DAF61AA-5A98-4049-A93E-477E5505141A}" type="datetimeFigureOut">
               <a:rPr lang="en-US" smtClean="0"/>
-              <a:t>8/11/2026</a:t>
+              <a:t>8/20/2026</a:t>
             </a:fld>
             <a:endParaRPr lang="en-US"/>
           </a:p>
@@ -1147,7 +1147,7 @@
           <a:p>
             <a:fld id="{0DAF61AA-5A98-4049-A93E-477E5505141A}" type="datetimeFigureOut">
               <a:rPr lang="en-US" smtClean="0"/>
-              <a:t>8/11/2026</a:t>
+              <a:t>8/20/2026</a:t>
             </a:fld>
             <a:endParaRPr lang="en-US"/>
           </a:p>
@@ -1415,7 +1415,7 @@
           <a:p>
             <a:fld id="{0DAF61AA-5A98-4049-A93E-477E5505141A}" type="datetimeFigureOut">
               <a:rPr lang="en-US" smtClean="0"/>
-              <a:t>8/11/2026</a:t>
+              <a:t>8/20/2026</a:t>
             </a:fld>
             <a:endParaRPr lang="en-US"/>
           </a:p>
@@ -1830,7 +1830,7 @@
           <a:p>
             <a:fld id="{0DAF61AA-5A98-4049-A93E-477E5505141A}" type="datetimeFigureOut">
               <a:rPr lang="en-US" smtClean="0"/>
-              <a:t>8/11/2026</a:t>
+              <a:t>8/20/2026</a:t>
             </a:fld>
             <a:endParaRPr lang="en-US"/>
           </a:p>
@@ -1972,7 +1972,7 @@
           <a:p>
             <a:fld id="{0DAF61AA-5A98-4049-A93E-477E5505141A}" type="datetimeFigureOut">
               <a:rPr lang="en-US" smtClean="0"/>
-              <a:t>8/11/2026</a:t>
+              <a:t>8/20/2026</a:t>
             </a:fld>
             <a:endParaRPr lang="en-US"/>
           </a:p>
@@ -2085,7 +2085,7 @@
           <a:p>
             <a:fld id="{0DAF61AA-5A98-4049-A93E-477E5505141A}" type="datetimeFigureOut">
               <a:rPr lang="en-US" smtClean="0"/>
-              <a:t>8/11/2026</a:t>
+              <a:t>8/20/2026</a:t>
             </a:fld>
             <a:endParaRPr lang="en-US"/>
           </a:p>
@@ -2398,7 +2398,7 @@
           <a:p>
             <a:fld id="{0DAF61AA-5A98-4049-A93E-477E5505141A}" type="datetimeFigureOut">
               <a:rPr lang="en-US" smtClean="0"/>
-              <a:t>8/11/2026</a:t>
+              <a:t>8/20/2026</a:t>
             </a:fld>
             <a:endParaRPr lang="en-US"/>
           </a:p>
@@ -2691,7 +2691,7 @@
           <a:p>
             <a:fld id="{0DAF61AA-5A98-4049-A93E-477E5505141A}" type="datetimeFigureOut">
               <a:rPr lang="en-US" smtClean="0"/>
-              <a:t>8/11/2026</a:t>
+              <a:t>8/20/2026</a:t>
             </a:fld>
             <a:endParaRPr lang="en-US"/>
           </a:p>
@@ -6404,7 +6404,7 @@
             <a:fld id="{0DAF61AA-5A98-4049-A93E-477E5505141A}" type="datetimeFigureOut">
               <a:rPr lang="en-US" smtClean="0"/>
               <a:pPr/>
-              <a:t>8/11/2026</a:t>
+              <a:t>8/20/2026</a:t>
             </a:fld>
             <a:endParaRPr lang="en-US" dirty="0"/>
           </a:p>
@@ -6903,7 +6903,7 @@
                 </a:solidFill>
                 <a:latin typeface="Abadi" panose="020B0604020104020204" pitchFamily="34" charset="0"/>
               </a:rPr>
-              <a:t> inferences generated across all human introns and filtered to remove signal below 0.01</a:t>
+              <a:t> inferences generated across whole introns and filtered to remove signal below 0.05</a:t>
             </a:r>
           </a:p>
           <a:p>
@@ -6915,7 +6915,7 @@
                 </a:solidFill>
                 <a:latin typeface="Abadi" panose="020B0604020104020204" pitchFamily="34" charset="0"/>
               </a:rPr>
-              <a:t>1,494,134 splice site inferences</a:t>
+              <a:t>794,192 splice site inferences</a:t>
             </a:r>
             <a:endParaRPr lang="en-GB" sz="1600" dirty="0">
               <a:solidFill>
@@ -6940,7 +6940,7 @@
         </p:nvSpPr>
         <p:spPr>
           <a:xfrm>
-            <a:off x="5450254" y="1318845"/>
+            <a:off x="6001130" y="1318845"/>
             <a:ext cx="508000" cy="495300"/>
           </a:xfrm>
           <a:prstGeom prst="ellipse">
@@ -6988,8 +6988,8 @@
         </p:nvSpPr>
         <p:spPr>
           <a:xfrm>
-            <a:off x="694592" y="2413000"/>
-            <a:ext cx="5468816" cy="4088915"/>
+            <a:off x="694592" y="2412999"/>
+            <a:ext cx="5468816" cy="5762873"/>
           </a:xfrm>
           <a:prstGeom prst="rect">
             <a:avLst/>
@@ -7038,7 +7038,7 @@
                 </a:solidFill>
                 <a:latin typeface="Abadi" panose="020B0604020104020204" pitchFamily="34" charset="0"/>
               </a:rPr>
-              <a:t> PRPF8 model predictions across introns</a:t>
+              <a:t> PRPF8 predictions across introns 242,946 Peaks</a:t>
             </a:r>
           </a:p>
           <a:p>
@@ -7050,7 +7050,7 @@
                 </a:solidFill>
                 <a:latin typeface="Abadi" panose="020B0604020104020204" pitchFamily="34" charset="0"/>
               </a:rPr>
-              <a:t>242,946 Peaks</a:t>
+              <a:t>rbpnet_clippy_f50_rollmean10_minHeightAdjust1.0_minPromAdjust1.0_minGeneCount5_Peaks.bed</a:t>
             </a:r>
           </a:p>
           <a:p>
@@ -7071,7 +7071,25 @@
                 </a:solidFill>
                 <a:latin typeface="Abadi" panose="020B0604020104020204" pitchFamily="34" charset="0"/>
               </a:rPr>
-              <a:t>PRPF8 </a:t>
+              <a:t>Merged PRPF8 </a:t>
+            </a:r>
+            <a:r>
+              <a:rPr lang="en-US" sz="1600" dirty="0" err="1">
+                <a:solidFill>
+                  <a:sysClr val="windowText" lastClr="000000"/>
+                </a:solidFill>
+                <a:latin typeface="Abadi" panose="020B0604020104020204" pitchFamily="34" charset="0"/>
+              </a:rPr>
+              <a:t>eCLIP</a:t>
+            </a:r>
+            <a:r>
+              <a:rPr lang="en-US" sz="1600" dirty="0">
+                <a:solidFill>
+                  <a:sysClr val="windowText" lastClr="000000"/>
+                </a:solidFill>
+                <a:latin typeface="Abadi" panose="020B0604020104020204" pitchFamily="34" charset="0"/>
+              </a:rPr>
+              <a:t> and </a:t>
             </a:r>
             <a:r>
               <a:rPr lang="en-US" sz="1600" dirty="0" err="1">
@@ -7089,7 +7107,7 @@
                 </a:solidFill>
                 <a:latin typeface="Abadi" panose="020B0604020104020204" pitchFamily="34" charset="0"/>
               </a:rPr>
-              <a:t> HepG2</a:t>
+              <a:t> 227,651 Peaks</a:t>
             </a:r>
           </a:p>
           <a:p>
@@ -7101,7 +7119,7 @@
                 </a:solidFill>
                 <a:latin typeface="Abadi" panose="020B0604020104020204" pitchFamily="34" charset="0"/>
               </a:rPr>
-              <a:t>3,108,179 Crosslinks</a:t>
+              <a:t>PRPF8_clippy_w0.5_rollmean80_minHeightAdjust3.0_minPromAdjust3.0_minGeneCount5_Peaks.bed</a:t>
             </a:r>
           </a:p>
           <a:p>
@@ -7122,7 +7140,7 @@
                 </a:solidFill>
                 <a:latin typeface="Abadi" panose="020B0604020104020204" pitchFamily="34" charset="0"/>
               </a:rPr>
-              <a:t>PRPF8 </a:t>
+              <a:t>Merged </a:t>
             </a:r>
             <a:r>
               <a:rPr lang="en-GB" sz="1600" dirty="0" err="1">
@@ -7131,7 +7149,7 @@
                 </a:solidFill>
                 <a:latin typeface="Abadi" panose="020B0604020104020204" pitchFamily="34" charset="0"/>
               </a:rPr>
-              <a:t>eCLIP</a:t>
+              <a:t>SmB</a:t>
             </a:r>
             <a:r>
               <a:rPr lang="en-GB" sz="1600" dirty="0">
@@ -7140,11 +7158,17 @@
                 </a:solidFill>
                 <a:latin typeface="Abadi" panose="020B0604020104020204" pitchFamily="34" charset="0"/>
               </a:rPr>
-              <a:t> HepG2</a:t>
-            </a:r>
-          </a:p>
-          <a:p>
-            <a:pPr algn="ctr"/>
+              <a:t> </a:t>
+            </a:r>
+            <a:r>
+              <a:rPr lang="en-GB" sz="1600" dirty="0" err="1">
+                <a:solidFill>
+                  <a:sysClr val="windowText" lastClr="000000"/>
+                </a:solidFill>
+                <a:latin typeface="Abadi" panose="020B0604020104020204" pitchFamily="34" charset="0"/>
+              </a:rPr>
+              <a:t>iCLIP</a:t>
+            </a:r>
             <a:r>
               <a:rPr lang="en-GB" sz="1600" dirty="0">
                 <a:solidFill>
@@ -7152,7 +7176,19 @@
                 </a:solidFill>
                 <a:latin typeface="Abadi" panose="020B0604020104020204" pitchFamily="34" charset="0"/>
               </a:rPr>
-              <a:t>78,581 Peaks (ENCODE)</a:t>
+              <a:t> 152,983 Peaks </a:t>
+            </a:r>
+          </a:p>
+          <a:p>
+            <a:pPr algn="ctr"/>
+            <a:r>
+              <a:rPr lang="en-GB" sz="1600" dirty="0">
+                <a:solidFill>
+                  <a:sysClr val="windowText" lastClr="000000"/>
+                </a:solidFill>
+                <a:latin typeface="Abadi" panose="020B0604020104020204" pitchFamily="34" charset="0"/>
+              </a:rPr>
+              <a:t>SmB_clippy_n40_w0.5_rollmean40_minHeightAdjust8.0_minPromAdjust5.0_minGeneCount5_Peaks.bed</a:t>
             </a:r>
           </a:p>
           <a:p>
@@ -7167,7 +7203,7 @@
           <a:p>
             <a:pPr algn="ctr"/>
             <a:r>
-              <a:rPr lang="en-GB" sz="1600" dirty="0">
+              <a:rPr lang="en-GB" sz="1400" dirty="0">
                 <a:solidFill>
                   <a:sysClr val="windowText" lastClr="000000"/>
                 </a:solidFill>
@@ -7180,7 +7216,7 @@
           <a:p>
             <a:pPr algn="ctr"/>
             <a:r>
-              <a:rPr lang="en-GB" sz="1600" dirty="0">
+              <a:rPr lang="en-GB" sz="1400" dirty="0">
                 <a:solidFill>
                   <a:sysClr val="windowText" lastClr="000000"/>
                 </a:solidFill>
@@ -7193,7 +7229,7 @@
           <a:p>
             <a:pPr algn="ctr"/>
             <a:r>
-              <a:rPr lang="en-GB" sz="1600" dirty="0">
+              <a:rPr lang="en-GB" sz="1400" dirty="0">
                 <a:solidFill>
                   <a:sysClr val="windowText" lastClr="000000"/>
                 </a:solidFill>
@@ -7202,6 +7238,71 @@
               </a:rPr>
               <a:t>-b \</a:t>
             </a:r>
+            <a:br>
+              <a:rPr lang="en-GB" sz="1400" dirty="0">
+                <a:solidFill>
+                  <a:sysClr val="windowText" lastClr="000000"/>
+                </a:solidFill>
+                <a:latin typeface="SimHei" panose="020B0503020204020204" pitchFamily="49" charset="-122"/>
+                <a:ea typeface="SimHei" panose="020B0503020204020204" pitchFamily="49" charset="-122"/>
+              </a:rPr>
+            </a:br>
+            <a:r>
+              <a:rPr lang="en-GB" sz="1400" dirty="0">
+                <a:solidFill>
+                  <a:sysClr val="windowText" lastClr="000000"/>
+                </a:solidFill>
+                <a:latin typeface="SimHei" panose="020B0503020204020204" pitchFamily="49" charset="-122"/>
+                <a:ea typeface="SimHei" panose="020B0503020204020204" pitchFamily="49" charset="-122"/>
+              </a:rPr>
+              <a:t>-c \</a:t>
+            </a:r>
+          </a:p>
+          <a:p>
+            <a:pPr algn="ctr"/>
+            <a:r>
+              <a:rPr lang="en-GB" sz="1400" dirty="0">
+                <a:solidFill>
+                  <a:sysClr val="windowText" lastClr="000000"/>
+                </a:solidFill>
+                <a:latin typeface="SimHei" panose="020B0503020204020204" pitchFamily="49" charset="-122"/>
+                <a:ea typeface="SimHei" panose="020B0503020204020204" pitchFamily="49" charset="-122"/>
+              </a:rPr>
+              <a:t>-s \</a:t>
+            </a:r>
+          </a:p>
+          <a:p>
+            <a:pPr algn="ctr"/>
+            <a:r>
+              <a:rPr lang="en-GB" sz="1400" dirty="0">
+                <a:solidFill>
+                  <a:sysClr val="windowText" lastClr="000000"/>
+                </a:solidFill>
+                <a:latin typeface="SimHei" panose="020B0503020204020204" pitchFamily="49" charset="-122"/>
+                <a:ea typeface="SimHei" panose="020B0503020204020204" pitchFamily="49" charset="-122"/>
+              </a:rPr>
+              <a:t>| awk ‘$NF &gt; 0’ </a:t>
+            </a:r>
+            <a:r>
+              <a:rPr lang="en-GB" sz="1400" dirty="0" err="1">
+                <a:solidFill>
+                  <a:sysClr val="windowText" lastClr="000000"/>
+                </a:solidFill>
+                <a:latin typeface="SimHei" panose="020B0503020204020204" pitchFamily="49" charset="-122"/>
+                <a:ea typeface="SimHei" panose="020B0503020204020204" pitchFamily="49" charset="-122"/>
+              </a:rPr>
+              <a:t>SupportedSpliceSites.bed</a:t>
+            </a:r>
+            <a:endParaRPr lang="en-GB" sz="1600" dirty="0">
+              <a:solidFill>
+                <a:sysClr val="windowText" lastClr="000000"/>
+              </a:solidFill>
+              <a:latin typeface="SimHei" panose="020B0503020204020204" pitchFamily="49" charset="-122"/>
+              <a:ea typeface="SimHei" panose="020B0503020204020204" pitchFamily="49" charset="-122"/>
+            </a:endParaRPr>
+          </a:p>
+          <a:p>
+            <a:pPr algn="ctr"/>
             <a:br>
               <a:rPr lang="en-GB" sz="1600" dirty="0">
                 <a:solidFill>
@@ -7212,58 +7313,44 @@
               </a:rPr>
             </a:br>
             <a:r>
-              <a:rPr lang="en-GB" sz="1600" dirty="0">
+              <a:rPr lang="en-US" sz="1600" dirty="0">
                 <a:solidFill>
                   <a:sysClr val="windowText" lastClr="000000"/>
                 </a:solidFill>
-                <a:latin typeface="SimHei" panose="020B0503020204020204" pitchFamily="49" charset="-122"/>
-                <a:ea typeface="SimHei" panose="020B0503020204020204" pitchFamily="49" charset="-122"/>
+                <a:latin typeface="Abadi" panose="020B0604020104020204" pitchFamily="34" charset="0"/>
               </a:rPr>
-              <a:t>-c \</a:t>
+              <a:t>Repeat with –v to remove splice sites within 100 bp of canonical splice sites</a:t>
             </a:r>
           </a:p>
           <a:p>
             <a:pPr algn="ctr"/>
             <a:r>
-              <a:rPr lang="en-GB" sz="1600" dirty="0">
+              <a:rPr lang="en-US" sz="1600" dirty="0" err="1">
                 <a:solidFill>
                   <a:sysClr val="windowText" lastClr="000000"/>
                 </a:solidFill>
-                <a:latin typeface="SimHei" panose="020B0503020204020204" pitchFamily="49" charset="-122"/>
-                <a:ea typeface="SimHei" panose="020B0503020204020204" pitchFamily="49" charset="-122"/>
+                <a:latin typeface="Abadi" panose="020B0604020104020204" pitchFamily="34" charset="0"/>
               </a:rPr>
-              <a:t>-s \</a:t>
-            </a:r>
+              <a:t>Wide_canonical_splice_sites.bed</a:t>
+            </a:r>
+            <a:endParaRPr lang="en-US" sz="1600" dirty="0">
+              <a:solidFill>
+                <a:sysClr val="windowText" lastClr="000000"/>
+              </a:solidFill>
+              <a:latin typeface="Abadi" panose="020B0604020104020204" pitchFamily="34" charset="0"/>
+            </a:endParaRPr>
           </a:p>
           <a:p>
             <a:pPr algn="ctr"/>
             <a:r>
-              <a:rPr lang="en-GB" sz="1600" dirty="0">
+              <a:rPr lang="en-US" sz="1600" dirty="0">
                 <a:solidFill>
                   <a:sysClr val="windowText" lastClr="000000"/>
                 </a:solidFill>
-                <a:latin typeface="SimHei" panose="020B0503020204020204" pitchFamily="49" charset="-122"/>
-                <a:ea typeface="SimHei" panose="020B0503020204020204" pitchFamily="49" charset="-122"/>
+                <a:latin typeface="Abadi" panose="020B0604020104020204" pitchFamily="34" charset="0"/>
               </a:rPr>
-              <a:t>| awk ‘$NF &gt; 0’ </a:t>
-            </a:r>
-            <a:r>
-              <a:rPr lang="en-GB" sz="1600" dirty="0" err="1">
-                <a:solidFill>
-                  <a:sysClr val="windowText" lastClr="000000"/>
-                </a:solidFill>
-                <a:latin typeface="SimHei" panose="020B0503020204020204" pitchFamily="49" charset="-122"/>
-                <a:ea typeface="SimHei" panose="020B0503020204020204" pitchFamily="49" charset="-122"/>
-              </a:rPr>
-              <a:t>SupportedSpliceSites.bed</a:t>
-            </a:r>
-            <a:endParaRPr lang="en-GB" sz="1600" dirty="0">
-              <a:solidFill>
-                <a:sysClr val="windowText" lastClr="000000"/>
-              </a:solidFill>
-              <a:latin typeface="SimHei" panose="020B0503020204020204" pitchFamily="49" charset="-122"/>
-              <a:ea typeface="SimHei" panose="020B0503020204020204" pitchFamily="49" charset="-122"/>
-            </a:endParaRPr>
+              <a:t>Total: 36,240 Predicted splice sites</a:t>
+            </a:r>
           </a:p>
         </p:txBody>
       </p:sp>
@@ -7382,126 +7469,6 @@
               <a:latin typeface="Raleway" pitchFamily="2" charset="0"/>
               <a:cs typeface="Posterama" panose="020B0504020200020000" pitchFamily="34" charset="0"/>
             </a:endParaRPr>
-          </a:p>
-        </p:txBody>
-      </p:sp>
-      <p:sp>
-        <p:nvSpPr>
-          <p:cNvPr id="12" name="Oval 11">
-            <a:extLst>
-              <a:ext uri="{FF2B5EF4-FFF2-40B4-BE49-F238E27FC236}">
-                <a16:creationId xmlns:a16="http://schemas.microsoft.com/office/drawing/2014/main" id="{84A3C5B3-0E4E-58AA-3355-3552F2F1365C}"/>
-              </a:ext>
-            </a:extLst>
-          </p:cNvPr>
-          <p:cNvSpPr/>
-          <p:nvPr/>
-        </p:nvSpPr>
-        <p:spPr>
-          <a:xfrm>
-            <a:off x="5450254" y="3962157"/>
-            <a:ext cx="508000" cy="495300"/>
-          </a:xfrm>
-          <a:prstGeom prst="ellipse">
-            <a:avLst/>
-          </a:prstGeom>
-        </p:spPr>
-        <p:style>
-          <a:lnRef idx="2">
-            <a:schemeClr val="accent1"/>
-          </a:lnRef>
-          <a:fillRef idx="1">
-            <a:schemeClr val="lt1"/>
-          </a:fillRef>
-          <a:effectRef idx="0">
-            <a:schemeClr val="accent1"/>
-          </a:effectRef>
-          <a:fontRef idx="minor">
-            <a:schemeClr val="dk1"/>
-          </a:fontRef>
-        </p:style>
-        <p:txBody>
-          <a:bodyPr rtlCol="0" anchor="ctr"/>
-          <a:lstStyle/>
-          <a:p>
-            <a:pPr algn="ctr"/>
-            <a:r>
-              <a:rPr lang="en-US" sz="1400" dirty="0"/>
-              <a:t>-b</a:t>
-            </a:r>
-            <a:endParaRPr lang="en-GB" sz="1400" dirty="0"/>
-          </a:p>
-        </p:txBody>
-      </p:sp>
-      <p:sp>
-        <p:nvSpPr>
-          <p:cNvPr id="18" name="Rectangle 17">
-            <a:extLst>
-              <a:ext uri="{FF2B5EF4-FFF2-40B4-BE49-F238E27FC236}">
-                <a16:creationId xmlns:a16="http://schemas.microsoft.com/office/drawing/2014/main" id="{85D6ECC2-3197-2E44-E421-12E3D15029A8}"/>
-              </a:ext>
-            </a:extLst>
-          </p:cNvPr>
-          <p:cNvSpPr/>
-          <p:nvPr/>
-        </p:nvSpPr>
-        <p:spPr>
-          <a:xfrm>
-            <a:off x="694592" y="6994040"/>
-            <a:ext cx="5468816" cy="1280258"/>
-          </a:xfrm>
-          <a:prstGeom prst="rect">
-            <a:avLst/>
-          </a:prstGeom>
-          <a:solidFill>
-            <a:schemeClr val="accent1">
-              <a:lumMod val="40000"/>
-              <a:lumOff val="60000"/>
-            </a:schemeClr>
-          </a:solidFill>
-        </p:spPr>
-        <p:style>
-          <a:lnRef idx="2">
-            <a:schemeClr val="accent1">
-              <a:shade val="15000"/>
-            </a:schemeClr>
-          </a:lnRef>
-          <a:fillRef idx="1">
-            <a:schemeClr val="accent1"/>
-          </a:fillRef>
-          <a:effectRef idx="0">
-            <a:schemeClr val="accent1"/>
-          </a:effectRef>
-          <a:fontRef idx="minor">
-            <a:schemeClr val="lt1"/>
-          </a:fontRef>
-        </p:style>
-        <p:txBody>
-          <a:bodyPr rtlCol="0" anchor="ctr"/>
-          <a:lstStyle/>
-          <a:p>
-            <a:pPr algn="ctr"/>
-            <a:r>
-              <a:rPr lang="en-US" sz="1600" dirty="0">
-                <a:solidFill>
-                  <a:sysClr val="windowText" lastClr="000000"/>
-                </a:solidFill>
-                <a:latin typeface="Abadi" panose="020B0604020104020204" pitchFamily="34" charset="0"/>
-              </a:rPr>
-              <a:t>Remove splice sites within 100 bp of canonical splice sites</a:t>
-            </a:r>
-          </a:p>
-          <a:p>
-            <a:pPr algn="ctr"/>
-            <a:r>
-              <a:rPr lang="en-US" sz="1600" dirty="0">
-                <a:solidFill>
-                  <a:sysClr val="windowText" lastClr="000000"/>
-                </a:solidFill>
-                <a:latin typeface="Abadi" panose="020B0604020104020204" pitchFamily="34" charset="0"/>
-              </a:rPr>
-              <a:t>30,200 Predicted splice sites</a:t>
-            </a:r>
           </a:p>
         </p:txBody>
       </p:sp>
@@ -7590,7 +7557,7 @@
                 </a:solidFill>
                 <a:latin typeface="Abadi" panose="020B0604020104020204" pitchFamily="34" charset="0"/>
               </a:rPr>
-              <a:t>15,172 Predicted splice sites</a:t>
+              <a:t>19,945 Predicted splice sites</a:t>
             </a:r>
           </a:p>
         </p:txBody>
@@ -7610,7 +7577,7 @@
         <p:spPr>
           <a:xfrm>
             <a:off x="694592" y="10440381"/>
-            <a:ext cx="5468816" cy="1280258"/>
+            <a:ext cx="5468816" cy="1519390"/>
           </a:xfrm>
           <a:prstGeom prst="rect">
             <a:avLst/>
@@ -7650,38 +7617,17 @@
                 </a:solidFill>
                 <a:latin typeface="Abadi" panose="020B0604020104020204" pitchFamily="34" charset="0"/>
               </a:rPr>
-              <a:t>Remove loci matching annotated Recount junctions (TCGA/SRA/</a:t>
-            </a:r>
-            <a:r>
-              <a:rPr lang="en-US" sz="1600" dirty="0" err="1">
-                <a:solidFill>
-                  <a:sysClr val="windowText" lastClr="000000"/>
-                </a:solidFill>
-                <a:latin typeface="Abadi" panose="020B0604020104020204" pitchFamily="34" charset="0"/>
-              </a:rPr>
-              <a:t>GTEx</a:t>
-            </a:r>
-            <a:r>
-              <a:rPr lang="en-US" sz="1600" dirty="0">
-                <a:solidFill>
-                  <a:sysClr val="windowText" lastClr="000000"/>
-                </a:solidFill>
-                <a:latin typeface="Abadi" panose="020B0604020104020204" pitchFamily="34" charset="0"/>
-              </a:rPr>
-              <a:t>, ±5 bp)</a:t>
+              <a:t>Pull FASTA using BED coordinates using SpliceAI_Inference.py to re-score inferences over a ±24nt window surrounding the loci</a:t>
             </a:r>
           </a:p>
           <a:p>
             <a:pPr algn="ctr"/>
-            <a:r>
-              <a:rPr lang="en-US" sz="1600" dirty="0">
-                <a:solidFill>
-                  <a:sysClr val="windowText" lastClr="000000"/>
-                </a:solidFill>
-                <a:latin typeface="Abadi" panose="020B0604020104020204" pitchFamily="34" charset="0"/>
-              </a:rPr>
-              <a:t>13,913 Predicted splice sites</a:t>
-            </a:r>
+            <a:endParaRPr lang="en-US" sz="1600" dirty="0">
+              <a:solidFill>
+                <a:sysClr val="windowText" lastClr="000000"/>
+              </a:solidFill>
+              <a:latin typeface="Abadi" panose="020B0604020104020204" pitchFamily="34" charset="0"/>
+            </a:endParaRPr>
           </a:p>
         </p:txBody>
       </p:sp>
@@ -7746,6 +7692,50 @@
       </p:sp>
       <p:sp>
         <p:nvSpPr>
+          <p:cNvPr id="2" name="Right Brace 1">
+            <a:extLst>
+              <a:ext uri="{FF2B5EF4-FFF2-40B4-BE49-F238E27FC236}">
+                <a16:creationId xmlns:a16="http://schemas.microsoft.com/office/drawing/2014/main" id="{F18A3004-090F-26E2-3A54-3E8AB0186268}"/>
+              </a:ext>
+            </a:extLst>
+          </p:cNvPr>
+          <p:cNvSpPr/>
+          <p:nvPr/>
+        </p:nvSpPr>
+        <p:spPr>
+          <a:xfrm>
+            <a:off x="5945663" y="2573839"/>
+            <a:ext cx="300349" cy="3014187"/>
+          </a:xfrm>
+          <a:prstGeom prst="rightBrace">
+            <a:avLst/>
+          </a:prstGeom>
+        </p:spPr>
+        <p:style>
+          <a:lnRef idx="3">
+            <a:schemeClr val="accent1"/>
+          </a:lnRef>
+          <a:fillRef idx="0">
+            <a:schemeClr val="accent1"/>
+          </a:fillRef>
+          <a:effectRef idx="2">
+            <a:schemeClr val="accent1"/>
+          </a:effectRef>
+          <a:fontRef idx="minor">
+            <a:schemeClr val="tx1"/>
+          </a:fontRef>
+        </p:style>
+        <p:txBody>
+          <a:bodyPr rtlCol="0" anchor="ctr"/>
+          <a:lstStyle/>
+          <a:p>
+            <a:pPr algn="ctr"/>
+            <a:endParaRPr lang="en-GB"/>
+          </a:p>
+        </p:txBody>
+      </p:sp>
+      <p:sp>
+        <p:nvSpPr>
           <p:cNvPr id="26" name="Rectangle 25">
             <a:extLst>
               <a:ext uri="{FF2B5EF4-FFF2-40B4-BE49-F238E27FC236}">
@@ -7794,12 +7784,60 @@
                 <a:latin typeface="Raleway" pitchFamily="2" charset="0"/>
                 <a:cs typeface="Posterama" panose="020B0504020200020000" pitchFamily="34" charset="0"/>
               </a:rPr>
-              <a:t>Recount3</a:t>
+              <a:t>Rescore locus</a:t>
             </a:r>
             <a:endParaRPr lang="en-GB" b="1" dirty="0">
               <a:latin typeface="Raleway" pitchFamily="2" charset="0"/>
               <a:cs typeface="Posterama" panose="020B0504020200020000" pitchFamily="34" charset="0"/>
             </a:endParaRPr>
+          </a:p>
+        </p:txBody>
+      </p:sp>
+      <p:sp>
+        <p:nvSpPr>
+          <p:cNvPr id="12" name="Oval 11">
+            <a:extLst>
+              <a:ext uri="{FF2B5EF4-FFF2-40B4-BE49-F238E27FC236}">
+                <a16:creationId xmlns:a16="http://schemas.microsoft.com/office/drawing/2014/main" id="{84A3C5B3-0E4E-58AA-3355-3552F2F1365C}"/>
+              </a:ext>
+            </a:extLst>
+          </p:cNvPr>
+          <p:cNvSpPr/>
+          <p:nvPr/>
+        </p:nvSpPr>
+        <p:spPr>
+          <a:xfrm>
+            <a:off x="6030438" y="3833283"/>
+            <a:ext cx="508000" cy="495300"/>
+          </a:xfrm>
+          <a:prstGeom prst="ellipse">
+            <a:avLst/>
+          </a:prstGeom>
+        </p:spPr>
+        <p:style>
+          <a:lnRef idx="2">
+            <a:schemeClr val="accent1"/>
+          </a:lnRef>
+          <a:fillRef idx="1">
+            <a:schemeClr val="lt1"/>
+          </a:fillRef>
+          <a:effectRef idx="0">
+            <a:schemeClr val="accent1"/>
+          </a:effectRef>
+          <a:fontRef idx="minor">
+            <a:schemeClr val="dk1"/>
+          </a:fontRef>
+        </p:style>
+        <p:txBody>
+          <a:bodyPr rtlCol="0" anchor="ctr"/>
+          <a:lstStyle/>
+          <a:p>
+            <a:pPr algn="ctr"/>
+            <a:r>
+              <a:rPr lang="en-US" sz="1400" dirty="0"/>
+              <a:t>-b</a:t>
+            </a:r>
+            <a:endParaRPr lang="en-GB" sz="1400" dirty="0"/>
           </a:p>
         </p:txBody>
       </p:sp>

</xml_diff>